<commit_message>
Clarify manuscript terminology and related-atlas provenance
</commit_message>
<xml_diff>
--- a/manuscript_release_2026_10/figures/Figure1_editable.pptx
+++ b/manuscript_release_2026_10/figures/Figure1_editable.pptx
@@ -2,13 +2,13 @@
 <file path=ppt/presentation.xml><?xml version="1.0" encoding="utf-8"?>
 <p:presentation xmlns:p="http://schemas.openxmlformats.org/presentationml/2006/main">
   <p:sldMasterIdLst>
-    <p:sldMasterId xmlns:r="http://schemas.openxmlformats.org/officeDocument/2006/relationships" id="2147483648" r:id="R72aec2eb1ac744af"/>
+    <p:sldMasterId xmlns:r="http://schemas.openxmlformats.org/officeDocument/2006/relationships" id="2147483648" r:id="R7bbad83df6934ef5"/>
   </p:sldMasterIdLst>
   <p:notesMasterIdLst>
-    <p:notesMasterId xmlns:r="http://schemas.openxmlformats.org/officeDocument/2006/relationships" r:id="R6f4b5edea83d42b0"/>
+    <p:notesMasterId xmlns:r="http://schemas.openxmlformats.org/officeDocument/2006/relationships" r:id="R7d7e937f95c24d75"/>
   </p:notesMasterIdLst>
   <p:sldIdLst>
-    <p:sldId xmlns:r="http://schemas.openxmlformats.org/officeDocument/2006/relationships" id="256" r:id="R7a9a810a7a344692"/>
+    <p:sldId xmlns:r="http://schemas.openxmlformats.org/officeDocument/2006/relationships" id="256" r:id="R2c82ff122d4441ed"/>
   </p:sldIdLst>
   <p:sldSz cx="14287500" cy="10001250"/>
   <p:notesSz cx="6858000" cy="9144000"/>
@@ -442,7 +442,7 @@
           <a:lstStyle xmlns:a="http://schemas.openxmlformats.org/drawingml/2006/main"/>
           <a:p xmlns:a="http://schemas.openxmlformats.org/drawingml/2006/main">
             <a:r>
-              <a:t>Study design and candidate annotation. Source data: https://github.com/jamesyoung93/Diazotrophic_Cyanobacteria_Pangenome/tree/282c2b46b5ef3382022d0ebcf6420c94732d8b75/manuscript_release_2026_10. The 426-genome matrix has 2286 protein families. Candidate discovery and genus-blocked predictive evaluation are separate analyses. The historical Model-Supported inventory includes 473 estimable positive contrasts plus three ubiquitous controls. Annotation layers are heuristic. The four biological contexts motivate experiments and do not establish functional modules. Scientific thresholds, exclusions and score changes appear in the accompanying manuscript caption and Methods.</a:t>
+              <a:t>Study design and candidate annotation. The 426-genome matrix has 2,286 protein families. The high-purity inventory contains 981 families. The residual-association inventory contains 473 estimable positive carrier contrasts and three ubiquitous controls. Candidate inventory ranking and prediction evaluation are separate analyses. Prediction fits feature filters within training folds. Annotations prioritize experiments without establishing independent functional validation. Sources and terminology: https://github.com/jamesyoung93/Diazotrophic_Cyanobacteria_Pangenome/tree/main/manuscript_release_2026_10.</a:t>
             </a:r>
           </a:p>
         </p:txBody>
@@ -510,7 +510,7 @@
   </p:cSld>
   <p:clrMap bg1="lt1" tx1="dk1" bg2="lt2" tx2="dk2" accent1="accent1" accent2="accent2" accent3="accent3" accent4="accent4" accent5="accent5" accent6="accent6" hlink="hlink" folHlink="folHlink"/>
   <p:sldLayoutIdLst>
-    <p:sldLayoutId xmlns:r="http://schemas.openxmlformats.org/officeDocument/2006/relationships" id="2147483649" r:id="R48ae658480ab4543"/>
+    <p:sldLayoutId xmlns:r="http://schemas.openxmlformats.org/officeDocument/2006/relationships" id="2147483649" r:id="R855899fdef5b47fe"/>
   </p:sldLayoutIdLst>
   <p:txStyles>
     <p:titleStyle>
@@ -1147,6 +1147,7 @@
           <a:lstStyle xmlns:a="http://schemas.openxmlformats.org/drawingml/2006/main"/>
           <a:p xmlns:a="http://schemas.openxmlformats.org/drawingml/2006/main">
             <a:pPr algn="ctr">
+              <a:buNone/>
               <a:defRPr sz="2175" b="1">
                 <a:solidFill>
                   <a:srgbClr val="FFFFFF"/>
@@ -1170,6 +1171,7 @@
           </a:p>
           <a:p xmlns:a="http://schemas.openxmlformats.org/drawingml/2006/main">
             <a:pPr algn="ctr">
+              <a:buNone/>
               <a:defRPr sz="2175" b="1">
                 <a:solidFill>
                   <a:srgbClr val="FFFFFF"/>
@@ -1284,6 +1286,7 @@
           <a:lstStyle xmlns:a="http://schemas.openxmlformats.org/drawingml/2006/main"/>
           <a:p xmlns:a="http://schemas.openxmlformats.org/drawingml/2006/main">
             <a:pPr algn="ctr">
+              <a:buNone/>
               <a:defRPr sz="2175" b="1">
                 <a:solidFill>
                   <a:srgbClr val="FFFFFF"/>
@@ -1307,6 +1310,7 @@
           </a:p>
           <a:p xmlns:a="http://schemas.openxmlformats.org/drawingml/2006/main">
             <a:pPr algn="ctr">
+              <a:buNone/>
               <a:defRPr sz="2175" b="1">
                 <a:solidFill>
                   <a:srgbClr val="FFFFFF"/>
@@ -1421,6 +1425,7 @@
           <a:lstStyle xmlns:a="http://schemas.openxmlformats.org/drawingml/2006/main"/>
           <a:p xmlns:a="http://schemas.openxmlformats.org/drawingml/2006/main">
             <a:pPr algn="ctr">
+              <a:buNone/>
               <a:defRPr sz="2175" b="1">
                 <a:solidFill>
                   <a:srgbClr val="FFFFFF"/>
@@ -1444,6 +1449,7 @@
           </a:p>
           <a:p xmlns:a="http://schemas.openxmlformats.org/drawingml/2006/main">
             <a:pPr algn="ctr">
+              <a:buNone/>
               <a:defRPr sz="2175" b="1">
                 <a:solidFill>
                   <a:srgbClr val="FFFFFF"/>
@@ -1558,6 +1564,7 @@
           <a:lstStyle xmlns:a="http://schemas.openxmlformats.org/drawingml/2006/main"/>
           <a:p xmlns:a="http://schemas.openxmlformats.org/drawingml/2006/main">
             <a:pPr algn="ctr">
+              <a:buNone/>
               <a:defRPr sz="2175" b="1">
                 <a:solidFill>
                   <a:srgbClr val="FFFFFF"/>
@@ -1581,6 +1588,7 @@
           </a:p>
           <a:p xmlns:a="http://schemas.openxmlformats.org/drawingml/2006/main">
             <a:pPr algn="ctr">
+              <a:buNone/>
               <a:defRPr sz="2175" b="1">
                 <a:solidFill>
                   <a:srgbClr val="FFFFFF"/>
@@ -1928,6 +1936,7 @@
           <a:lstStyle xmlns:a="http://schemas.openxmlformats.org/drawingml/2006/main"/>
           <a:p xmlns:a="http://schemas.openxmlformats.org/drawingml/2006/main">
             <a:pPr algn="ctr">
+              <a:buNone/>
               <a:defRPr sz="2400" b="1">
                 <a:solidFill>
                   <a:srgbClr val="172D38"/>
@@ -1985,6 +1994,7 @@
           <a:lstStyle xmlns:a="http://schemas.openxmlformats.org/drawingml/2006/main"/>
           <a:p xmlns:a="http://schemas.openxmlformats.org/drawingml/2006/main">
             <a:pPr algn="ctr">
+              <a:buNone/>
               <a:defRPr sz="2325" b="1">
                 <a:solidFill>
                   <a:srgbClr val="172D38"/>
@@ -2076,6 +2086,7 @@
           <a:lstStyle xmlns:a="http://schemas.openxmlformats.org/drawingml/2006/main"/>
           <a:p xmlns:a="http://schemas.openxmlformats.org/drawingml/2006/main">
             <a:pPr algn="ctr">
+              <a:buNone/>
               <a:defRPr sz="2175" b="1">
                 <a:solidFill>
                   <a:srgbClr val="FFFFFF"/>
@@ -2167,6 +2178,7 @@
           <a:lstStyle xmlns:a="http://schemas.openxmlformats.org/drawingml/2006/main"/>
           <a:p xmlns:a="http://schemas.openxmlformats.org/drawingml/2006/main">
             <a:pPr algn="ctr">
+              <a:buNone/>
               <a:defRPr sz="2175" b="1">
                 <a:solidFill>
                   <a:srgbClr val="FFFFFF"/>
@@ -2258,6 +2270,7 @@
           <a:lstStyle xmlns:a="http://schemas.openxmlformats.org/drawingml/2006/main"/>
           <a:p xmlns:a="http://schemas.openxmlformats.org/drawingml/2006/main">
             <a:pPr algn="ctr">
+              <a:buNone/>
               <a:defRPr sz="2175" b="1">
                 <a:solidFill>
                   <a:srgbClr val="FFFFFF"/>
@@ -4107,6 +4120,7 @@
           <a:lstStyle xmlns:a="http://schemas.openxmlformats.org/drawingml/2006/main"/>
           <a:p xmlns:a="http://schemas.openxmlformats.org/drawingml/2006/main">
             <a:pPr algn="l">
+              <a:buNone/>
               <a:defRPr sz="2175" b="0">
                 <a:solidFill>
                   <a:srgbClr val="172D38"/>
@@ -4130,6 +4144,7 @@
           </a:p>
           <a:p xmlns:a="http://schemas.openxmlformats.org/drawingml/2006/main">
             <a:pPr algn="l">
+              <a:buNone/>
               <a:defRPr sz="2175" b="0">
                 <a:solidFill>
                   <a:srgbClr val="172D38"/>
@@ -4187,6 +4202,7 @@
           <a:lstStyle xmlns:a="http://schemas.openxmlformats.org/drawingml/2006/main"/>
           <a:p xmlns:a="http://schemas.openxmlformats.org/drawingml/2006/main">
             <a:pPr algn="ctr">
+              <a:buNone/>
               <a:defRPr sz="2400" b="1">
                 <a:solidFill>
                   <a:srgbClr val="172D38"/>
@@ -4362,6 +4378,7 @@
           <a:lstStyle xmlns:a="http://schemas.openxmlformats.org/drawingml/2006/main"/>
           <a:p xmlns:a="http://schemas.openxmlformats.org/drawingml/2006/main">
             <a:pPr algn="ctr">
+              <a:buNone/>
               <a:defRPr sz="2325" b="1">
                 <a:solidFill>
                   <a:srgbClr val="172D38"/>
@@ -4385,6 +4402,7 @@
           </a:p>
           <a:p xmlns:a="http://schemas.openxmlformats.org/drawingml/2006/main">
             <a:pPr algn="ctr">
+              <a:buNone/>
               <a:defRPr sz="2325" b="1">
                 <a:solidFill>
                   <a:srgbClr val="172D38"/>
@@ -4442,6 +4460,7 @@
           <a:lstStyle xmlns:a="http://schemas.openxmlformats.org/drawingml/2006/main"/>
           <a:p xmlns:a="http://schemas.openxmlformats.org/drawingml/2006/main">
             <a:pPr algn="ctr">
+              <a:buNone/>
               <a:defRPr sz="2100" b="0">
                 <a:solidFill>
                   <a:srgbClr val="172D38"/>
@@ -4499,6 +4518,7 @@
           <a:lstStyle xmlns:a="http://schemas.openxmlformats.org/drawingml/2006/main"/>
           <a:p xmlns:a="http://schemas.openxmlformats.org/drawingml/2006/main">
             <a:pPr algn="ctr">
+              <a:buNone/>
               <a:defRPr sz="2100" b="1">
                 <a:solidFill>
                   <a:srgbClr val="2F6F96"/>
@@ -4590,6 +4610,7 @@
           <a:lstStyle xmlns:a="http://schemas.openxmlformats.org/drawingml/2006/main"/>
           <a:p xmlns:a="http://schemas.openxmlformats.org/drawingml/2006/main">
             <a:pPr algn="ctr">
+              <a:buNone/>
               <a:defRPr sz="2550" b="1">
                 <a:solidFill>
                   <a:srgbClr val="172D38"/>
@@ -4608,7 +4629,7 @@
                 <a:ea typeface="Calibri"/>
                 <a:cs typeface="Calibri"/>
               </a:rPr>
-              <a:t>Highly Pure</a:t>
+              <a:t>High purity</a:t>
             </a:r>
           </a:p>
         </p:txBody>
@@ -4647,6 +4668,7 @@
           <a:lstStyle xmlns:a="http://schemas.openxmlformats.org/drawingml/2006/main"/>
           <a:p xmlns:a="http://schemas.openxmlformats.org/drawingml/2006/main">
             <a:pPr algn="ctr">
+              <a:buNone/>
               <a:defRPr sz="4050" b="1">
                 <a:solidFill>
                   <a:srgbClr val="234F28"/>
@@ -4704,6 +4726,7 @@
           <a:lstStyle xmlns:a="http://schemas.openxmlformats.org/drawingml/2006/main"/>
           <a:p xmlns:a="http://schemas.openxmlformats.org/drawingml/2006/main">
             <a:pPr algn="ctr">
+              <a:buNone/>
               <a:defRPr sz="2400" b="0">
                 <a:solidFill>
                   <a:srgbClr val="172D38"/>
@@ -4761,6 +4784,7 @@
           <a:lstStyle xmlns:a="http://schemas.openxmlformats.org/drawingml/2006/main"/>
           <a:p xmlns:a="http://schemas.openxmlformats.org/drawingml/2006/main">
             <a:pPr algn="ctr">
+              <a:buNone/>
               <a:defRPr sz="2175" b="0">
                 <a:solidFill>
                   <a:srgbClr val="172D38"/>
@@ -4784,6 +4808,7 @@
           </a:p>
           <a:p xmlns:a="http://schemas.openxmlformats.org/drawingml/2006/main">
             <a:pPr algn="ctr">
+              <a:buNone/>
               <a:defRPr sz="2175" b="0">
                 <a:solidFill>
                   <a:srgbClr val="172D38"/>
@@ -4857,8 +4882,8 @@
         </p:nvSpPr>
         <p:spPr>
           <a:xfrm xmlns:a="http://schemas.openxmlformats.org/drawingml/2006/main">
-            <a:off x="3467100" y="5953125"/>
-            <a:ext cx="2686050" cy="485775"/>
+            <a:off x="3467100" y="5810250"/>
+            <a:ext cx="2686050" cy="809625"/>
           </a:xfrm>
           <a:prstGeom xmlns:a="http://schemas.openxmlformats.org/drawingml/2006/main" prst="rect">
             <a:avLst/>
@@ -4875,6 +4900,7 @@
           <a:lstStyle xmlns:a="http://schemas.openxmlformats.org/drawingml/2006/main"/>
           <a:p xmlns:a="http://schemas.openxmlformats.org/drawingml/2006/main">
             <a:pPr algn="ctr">
+              <a:buNone/>
               <a:defRPr sz="2400" b="1">
                 <a:solidFill>
                   <a:srgbClr val="172D38"/>
@@ -4893,7 +4919,8 @@
                 <a:ea typeface="Calibri"/>
                 <a:cs typeface="Calibri"/>
               </a:rPr>
-              <a:t>Model-Supported</a:t>
+              <a:t>Residual
+association</a:t>
             </a:r>
           </a:p>
         </p:txBody>
@@ -4932,6 +4959,7 @@
           <a:lstStyle xmlns:a="http://schemas.openxmlformats.org/drawingml/2006/main"/>
           <a:p xmlns:a="http://schemas.openxmlformats.org/drawingml/2006/main">
             <a:pPr algn="ctr">
+              <a:buNone/>
               <a:defRPr sz="4050" b="1">
                 <a:solidFill>
                   <a:srgbClr val="725116"/>
@@ -4989,6 +5017,7 @@
           <a:lstStyle xmlns:a="http://schemas.openxmlformats.org/drawingml/2006/main"/>
           <a:p xmlns:a="http://schemas.openxmlformats.org/drawingml/2006/main">
             <a:pPr algn="ctr">
+              <a:buNone/>
               <a:defRPr sz="2400" b="0">
                 <a:solidFill>
                   <a:srgbClr val="172D38"/>
@@ -5046,6 +5075,7 @@
           <a:lstStyle xmlns:a="http://schemas.openxmlformats.org/drawingml/2006/main"/>
           <a:p xmlns:a="http://schemas.openxmlformats.org/drawingml/2006/main">
             <a:pPr algn="ctr">
+              <a:buNone/>
               <a:defRPr sz="2175" b="0">
                 <a:solidFill>
                   <a:srgbClr val="172D38"/>
@@ -5064,11 +5094,12 @@
                 <a:ea typeface="Calibri"/>
                 <a:cs typeface="Calibri"/>
               </a:rPr>
-              <a:t>Accessory</a:t>
+              <a:t>473 candidates</a:t>
             </a:r>
           </a:p>
           <a:p xmlns:a="http://schemas.openxmlformats.org/drawingml/2006/main">
             <a:pPr algn="ctr">
+              <a:buNone/>
               <a:defRPr sz="2175" b="0">
                 <a:solidFill>
                   <a:srgbClr val="172D38"/>
@@ -5087,7 +5118,7 @@
                 <a:ea typeface="Calibri"/>
                 <a:cs typeface="Calibri"/>
               </a:rPr>
-              <a:t>candidate families</a:t>
+              <a:t>+ 3 controls</a:t>
             </a:r>
           </a:p>
         </p:txBody>
@@ -5366,6 +5397,7 @@
           <a:lstStyle xmlns:a="http://schemas.openxmlformats.org/drawingml/2006/main"/>
           <a:p xmlns:a="http://schemas.openxmlformats.org/drawingml/2006/main">
             <a:pPr algn="ctr">
+              <a:buNone/>
               <a:defRPr sz="2325" b="1">
                 <a:solidFill>
                   <a:srgbClr val="172D38"/>
@@ -5389,6 +5421,7 @@
           </a:p>
           <a:p xmlns:a="http://schemas.openxmlformats.org/drawingml/2006/main">
             <a:pPr algn="ctr">
+              <a:buNone/>
               <a:defRPr sz="2325" b="1">
                 <a:solidFill>
                   <a:srgbClr val="172D38"/>
@@ -5700,6 +5733,7 @@
           <a:lstStyle xmlns:a="http://schemas.openxmlformats.org/drawingml/2006/main"/>
           <a:p xmlns:a="http://schemas.openxmlformats.org/drawingml/2006/main">
             <a:pPr algn="ctr">
+              <a:buNone/>
               <a:defRPr sz="2250" b="1">
                 <a:solidFill>
                   <a:srgbClr val="172D38"/>
@@ -5723,6 +5757,7 @@
           </a:p>
           <a:p xmlns:a="http://schemas.openxmlformats.org/drawingml/2006/main">
             <a:pPr algn="ctr">
+              <a:buNone/>
               <a:defRPr sz="2250" b="1">
                 <a:solidFill>
                   <a:srgbClr val="172D38"/>
@@ -6144,6 +6179,7 @@
           <a:lstStyle xmlns:a="http://schemas.openxmlformats.org/drawingml/2006/main"/>
           <a:p xmlns:a="http://schemas.openxmlformats.org/drawingml/2006/main">
             <a:pPr algn="ctr">
+              <a:buNone/>
               <a:defRPr sz="2325" b="1">
                 <a:solidFill>
                   <a:srgbClr val="172D38"/>
@@ -6167,6 +6203,7 @@
           </a:p>
           <a:p xmlns:a="http://schemas.openxmlformats.org/drawingml/2006/main">
             <a:pPr algn="ctr">
+              <a:buNone/>
               <a:defRPr sz="2325" b="1">
                 <a:solidFill>
                   <a:srgbClr val="172D38"/>
@@ -6576,6 +6613,7 @@
           <a:lstStyle xmlns:a="http://schemas.openxmlformats.org/drawingml/2006/main"/>
           <a:p xmlns:a="http://schemas.openxmlformats.org/drawingml/2006/main">
             <a:pPr algn="ctr">
+              <a:buNone/>
               <a:defRPr sz="2100" b="1">
                 <a:solidFill>
                   <a:srgbClr val="A66B00"/>
@@ -6949,6 +6987,7 @@
           <a:lstStyle xmlns:a="http://schemas.openxmlformats.org/drawingml/2006/main"/>
           <a:p xmlns:a="http://schemas.openxmlformats.org/drawingml/2006/main">
             <a:pPr algn="ctr">
+              <a:buNone/>
               <a:defRPr sz="2175" b="0">
                 <a:solidFill>
                   <a:srgbClr val="172D38"/>
@@ -6972,6 +7011,7 @@
           </a:p>
           <a:p xmlns:a="http://schemas.openxmlformats.org/drawingml/2006/main">
             <a:pPr algn="ctr">
+              <a:buNone/>
               <a:defRPr sz="2175" b="0">
                 <a:solidFill>
                   <a:srgbClr val="172D38"/>
@@ -7029,6 +7069,7 @@
           <a:lstStyle xmlns:a="http://schemas.openxmlformats.org/drawingml/2006/main"/>
           <a:p xmlns:a="http://schemas.openxmlformats.org/drawingml/2006/main">
             <a:pPr algn="ctr">
+              <a:buNone/>
               <a:defRPr sz="2100" b="0">
                 <a:solidFill>
                   <a:srgbClr val="172D38"/>
@@ -7052,6 +7093,7 @@
           </a:p>
           <a:p xmlns:a="http://schemas.openxmlformats.org/drawingml/2006/main">
             <a:pPr algn="ctr">
+              <a:buNone/>
               <a:defRPr sz="2100" b="0">
                 <a:solidFill>
                   <a:srgbClr val="172D38"/>
@@ -7943,6 +7985,7 @@
           <a:lstStyle xmlns:a="http://schemas.openxmlformats.org/drawingml/2006/main"/>
           <a:p xmlns:a="http://schemas.openxmlformats.org/drawingml/2006/main">
             <a:pPr algn="ctr">
+              <a:buNone/>
               <a:defRPr sz="2325" b="1">
                 <a:solidFill>
                   <a:srgbClr val="76352B"/>
@@ -8290,6 +8333,7 @@
           <a:lstStyle xmlns:a="http://schemas.openxmlformats.org/drawingml/2006/main"/>
           <a:p xmlns:a="http://schemas.openxmlformats.org/drawingml/2006/main">
             <a:pPr algn="ctr">
+              <a:buNone/>
               <a:defRPr sz="2100" b="0">
                 <a:solidFill>
                   <a:srgbClr val="172D38"/>
@@ -8347,6 +8391,7 @@
           <a:lstStyle xmlns:a="http://schemas.openxmlformats.org/drawingml/2006/main"/>
           <a:p xmlns:a="http://schemas.openxmlformats.org/drawingml/2006/main">
             <a:pPr algn="ctr">
+              <a:buNone/>
               <a:defRPr sz="2100" b="0">
                 <a:solidFill>
                   <a:srgbClr val="172D38"/>
@@ -8404,6 +8449,7 @@
           <a:lstStyle xmlns:a="http://schemas.openxmlformats.org/drawingml/2006/main"/>
           <a:p xmlns:a="http://schemas.openxmlformats.org/drawingml/2006/main">
             <a:pPr algn="ctr">
+              <a:buNone/>
               <a:defRPr sz="2250" b="1">
                 <a:solidFill>
                   <a:srgbClr val="172D38"/>
@@ -8703,6 +8749,7 @@
           <a:lstStyle xmlns:a="http://schemas.openxmlformats.org/drawingml/2006/main"/>
           <a:p xmlns:a="http://schemas.openxmlformats.org/drawingml/2006/main">
             <a:pPr algn="ctr">
+              <a:buNone/>
               <a:defRPr sz="2100" b="0">
                 <a:solidFill>
                   <a:srgbClr val="172D38"/>
@@ -8726,6 +8773,7 @@
           </a:p>
           <a:p xmlns:a="http://schemas.openxmlformats.org/drawingml/2006/main">
             <a:pPr algn="ctr">
+              <a:buNone/>
               <a:defRPr sz="2100" b="0">
                 <a:solidFill>
                   <a:srgbClr val="172D38"/>
@@ -8749,6 +8797,7 @@
           </a:p>
           <a:p xmlns:a="http://schemas.openxmlformats.org/drawingml/2006/main">
             <a:pPr algn="ctr">
+              <a:buNone/>
               <a:defRPr sz="2100" b="0">
                 <a:solidFill>
                   <a:srgbClr val="172D38"/>
@@ -9343,6 +9392,7 @@
           <a:lstStyle xmlns:a="http://schemas.openxmlformats.org/drawingml/2006/main"/>
           <a:p xmlns:a="http://schemas.openxmlformats.org/drawingml/2006/main">
             <a:pPr algn="ctr">
+              <a:buNone/>
               <a:defRPr sz="2100" b="0">
                 <a:solidFill>
                   <a:srgbClr val="172D38"/>
@@ -9366,6 +9416,7 @@
           </a:p>
           <a:p xmlns:a="http://schemas.openxmlformats.org/drawingml/2006/main">
             <a:pPr algn="ctr">
+              <a:buNone/>
               <a:defRPr sz="2100" b="0">
                 <a:solidFill>
                   <a:srgbClr val="172D38"/>

</xml_diff>